<commit_message>
Updated Slide 1 in both markdown and PPTX presentation files to reflect CRM and AI Intake values
</commit_message>
<xml_diff>
--- a/final_presentation_slides_ar.pptx
+++ b/final_presentation_slides_ar.pptx
@@ -5,17 +5,17 @@
     <p:sldMasterId id="2147483648" r:id="rId1"/>
   </p:sldMasterIdLst>
   <p:sldIdLst>
-    <p:sldId id="256" r:id="rId7"/>
-    <p:sldId id="257" r:id="rId8"/>
-    <p:sldId id="258" r:id="rId9"/>
-    <p:sldId id="259" r:id="rId10"/>
-    <p:sldId id="260" r:id="rId11"/>
-    <p:sldId id="261" r:id="rId12"/>
-    <p:sldId id="262" r:id="rId13"/>
-    <p:sldId id="263" r:id="rId14"/>
-    <p:sldId id="264" r:id="rId15"/>
+    <p:sldId id="256" r:id="rId2"/>
+    <p:sldId id="257" r:id="rId3"/>
+    <p:sldId id="258" r:id="rId4"/>
+    <p:sldId id="259" r:id="rId5"/>
+    <p:sldId id="260" r:id="rId6"/>
+    <p:sldId id="261" r:id="rId7"/>
+    <p:sldId id="262" r:id="rId8"/>
+    <p:sldId id="263" r:id="rId9"/>
+    <p:sldId id="264" r:id="rId10"/>
   </p:sldIdLst>
-  <p:sldSz cx="12191695" cy="6858000" type="screen4x3"/>
+  <p:sldSz cx="12192000" cy="6858000"/>
   <p:notesSz cx="6858000" cy="9144000"/>
   <p:defaultTextStyle>
     <a:defPPr>
@@ -112,7 +112,52 @@
       </a:defRPr>
     </a:lvl9pPr>
   </p:defaultTextStyle>
+  <p:extLst>
+    <p:ext uri="{EFAFB233-063F-42B5-8137-9DF3F51BA10A}">
+      <p15:sldGuideLst xmlns:p15="http://schemas.microsoft.com/office/powerpoint/2012/main">
+        <p15:guide id="1" orient="horz" pos="2160">
+          <p15:clr>
+            <a:srgbClr val="A4A3A4"/>
+          </p15:clr>
+        </p15:guide>
+        <p15:guide id="2" pos="2880">
+          <p15:clr>
+            <a:srgbClr val="A4A3A4"/>
+          </p15:clr>
+        </p15:guide>
+      </p15:sldGuideLst>
+    </p:ext>
+  </p:extLst>
 </p:presentation>
+</file>
+
+<file path=ppt/changesInfos/changesInfo1.xml><?xml version="1.0" encoding="utf-8"?>
+<pc:chgInfo xmlns:a="http://schemas.openxmlformats.org/drawingml/2006/main" xmlns:r="http://schemas.openxmlformats.org/officeDocument/2006/relationships" xmlns:ac="http://schemas.microsoft.com/office/drawing/2013/main/command" xmlns:pc="http://schemas.microsoft.com/office/powerpoint/2013/main/command">
+  <pc:docChgLst>
+    <pc:chgData name="Noor Aioby" userId="38146ebc-8545-46bf-9d83-28dbd61da7d6" providerId="ADAL" clId="{9D132DA4-9AD7-4C07-B54E-5655E6903186}"/>
+    <pc:docChg chg="modSld">
+      <pc:chgData name="Noor Aioby" userId="38146ebc-8545-46bf-9d83-28dbd61da7d6" providerId="ADAL" clId="{9D132DA4-9AD7-4C07-B54E-5655E6903186}" dt="2026-07-09T07:05:25.257" v="0" actId="20577"/>
+      <pc:docMkLst>
+        <pc:docMk/>
+      </pc:docMkLst>
+      <pc:sldChg chg="modSp mod">
+        <pc:chgData name="Noor Aioby" userId="38146ebc-8545-46bf-9d83-28dbd61da7d6" providerId="ADAL" clId="{9D132DA4-9AD7-4C07-B54E-5655E6903186}" dt="2026-07-09T07:05:25.257" v="0" actId="20577"/>
+        <pc:sldMkLst>
+          <pc:docMk/>
+          <pc:sldMk cId="0" sldId="256"/>
+        </pc:sldMkLst>
+        <pc:spChg chg="mod">
+          <ac:chgData name="Noor Aioby" userId="38146ebc-8545-46bf-9d83-28dbd61da7d6" providerId="ADAL" clId="{9D132DA4-9AD7-4C07-B54E-5655E6903186}" dt="2026-07-09T07:05:25.257" v="0" actId="20577"/>
+          <ac:spMkLst>
+            <pc:docMk/>
+            <pc:sldMk cId="0" sldId="256"/>
+            <ac:spMk id="4" creationId="{00000000-0000-0000-0000-000000000000}"/>
+          </ac:spMkLst>
+        </pc:spChg>
+      </pc:sldChg>
+    </pc:docChg>
+  </pc:docChgLst>
+</pc:chgInfo>
 </file>
 
 <file path=ppt/slideLayouts/slideLayout1.xml><?xml version="1.0" encoding="utf-8"?>
@@ -153,10 +198,9 @@
           <a:lstStyle/>
           <a:p>
             <a:r>
-              <a:rPr lang="en-US" smtClean="0"/>
+              <a:rPr lang="en-US"/>
               <a:t>Click to edit Master title style</a:t>
             </a:r>
-            <a:endParaRPr lang="en-US"/>
           </a:p>
         </p:txBody>
       </p:sp>
@@ -272,10 +316,9 @@
           </a:lstStyle>
           <a:p>
             <a:r>
-              <a:rPr lang="en-US" smtClean="0"/>
+              <a:rPr lang="en-US"/>
               <a:t>Click to edit Master subtitle style</a:t>
             </a:r>
-            <a:endParaRPr lang="en-US"/>
           </a:p>
         </p:txBody>
       </p:sp>
@@ -296,7 +339,7 @@
           <a:p>
             <a:fld id="{5BCAD085-E8A6-8845-BD4E-CB4CCA059FC4}" type="datetimeFigureOut">
               <a:rPr lang="en-US" smtClean="0"/>
-              <a:t>1/27/13</a:t>
+              <a:t>7/9/2026</a:t>
             </a:fld>
             <a:endParaRPr lang="en-US"/>
           </a:p>
@@ -390,10 +433,9 @@
           <a:lstStyle/>
           <a:p>
             <a:r>
-              <a:rPr lang="en-US" smtClean="0"/>
+              <a:rPr lang="en-US"/>
               <a:t>Click to edit Master title style</a:t>
             </a:r>
-            <a:endParaRPr lang="en-US"/>
           </a:p>
         </p:txBody>
       </p:sp>
@@ -414,38 +456,37 @@
           <a:p>
             <a:pPr lvl="0"/>
             <a:r>
-              <a:rPr lang="en-US" smtClean="0"/>
+              <a:rPr lang="en-US"/>
               <a:t>Click to edit Master text styles</a:t>
             </a:r>
           </a:p>
           <a:p>
             <a:pPr lvl="1"/>
             <a:r>
-              <a:rPr lang="en-US" smtClean="0"/>
+              <a:rPr lang="en-US"/>
               <a:t>Second level</a:t>
             </a:r>
           </a:p>
           <a:p>
             <a:pPr lvl="2"/>
             <a:r>
-              <a:rPr lang="en-US" smtClean="0"/>
+              <a:rPr lang="en-US"/>
               <a:t>Third level</a:t>
             </a:r>
           </a:p>
           <a:p>
             <a:pPr lvl="3"/>
             <a:r>
-              <a:rPr lang="en-US" smtClean="0"/>
+              <a:rPr lang="en-US"/>
               <a:t>Fourth level</a:t>
             </a:r>
           </a:p>
           <a:p>
             <a:pPr lvl="4"/>
             <a:r>
-              <a:rPr lang="en-US" smtClean="0"/>
+              <a:rPr lang="en-US"/>
               <a:t>Fifth level</a:t>
             </a:r>
-            <a:endParaRPr lang="en-US"/>
           </a:p>
         </p:txBody>
       </p:sp>
@@ -466,7 +507,7 @@
           <a:p>
             <a:fld id="{5BCAD085-E8A6-8845-BD4E-CB4CCA059FC4}" type="datetimeFigureOut">
               <a:rPr lang="en-US" smtClean="0"/>
-              <a:t>1/27/13</a:t>
+              <a:t>7/9/2026</a:t>
             </a:fld>
             <a:endParaRPr lang="en-US"/>
           </a:p>
@@ -565,10 +606,9 @@
           <a:lstStyle/>
           <a:p>
             <a:r>
-              <a:rPr lang="en-US" smtClean="0"/>
+              <a:rPr lang="en-US"/>
               <a:t>Click to edit Master title style</a:t>
             </a:r>
-            <a:endParaRPr lang="en-US"/>
           </a:p>
         </p:txBody>
       </p:sp>
@@ -594,38 +634,37 @@
           <a:p>
             <a:pPr lvl="0"/>
             <a:r>
-              <a:rPr lang="en-US" smtClean="0"/>
+              <a:rPr lang="en-US"/>
               <a:t>Click to edit Master text styles</a:t>
             </a:r>
           </a:p>
           <a:p>
             <a:pPr lvl="1"/>
             <a:r>
-              <a:rPr lang="en-US" smtClean="0"/>
+              <a:rPr lang="en-US"/>
               <a:t>Second level</a:t>
             </a:r>
           </a:p>
           <a:p>
             <a:pPr lvl="2"/>
             <a:r>
-              <a:rPr lang="en-US" smtClean="0"/>
+              <a:rPr lang="en-US"/>
               <a:t>Third level</a:t>
             </a:r>
           </a:p>
           <a:p>
             <a:pPr lvl="3"/>
             <a:r>
-              <a:rPr lang="en-US" smtClean="0"/>
+              <a:rPr lang="en-US"/>
               <a:t>Fourth level</a:t>
             </a:r>
           </a:p>
           <a:p>
             <a:pPr lvl="4"/>
             <a:r>
-              <a:rPr lang="en-US" smtClean="0"/>
+              <a:rPr lang="en-US"/>
               <a:t>Fifth level</a:t>
             </a:r>
-            <a:endParaRPr lang="en-US"/>
           </a:p>
         </p:txBody>
       </p:sp>
@@ -646,7 +685,7 @@
           <a:p>
             <a:fld id="{5BCAD085-E8A6-8845-BD4E-CB4CCA059FC4}" type="datetimeFigureOut">
               <a:rPr lang="en-US" smtClean="0"/>
-              <a:t>1/27/13</a:t>
+              <a:t>7/9/2026</a:t>
             </a:fld>
             <a:endParaRPr lang="en-US"/>
           </a:p>
@@ -740,10 +779,9 @@
           <a:lstStyle/>
           <a:p>
             <a:r>
-              <a:rPr lang="en-US" smtClean="0"/>
+              <a:rPr lang="en-US"/>
               <a:t>Click to edit Master title style</a:t>
             </a:r>
-            <a:endParaRPr lang="en-US"/>
           </a:p>
         </p:txBody>
       </p:sp>
@@ -764,38 +802,37 @@
           <a:p>
             <a:pPr lvl="0"/>
             <a:r>
-              <a:rPr lang="en-US" smtClean="0"/>
+              <a:rPr lang="en-US"/>
               <a:t>Click to edit Master text styles</a:t>
             </a:r>
           </a:p>
           <a:p>
             <a:pPr lvl="1"/>
             <a:r>
-              <a:rPr lang="en-US" smtClean="0"/>
+              <a:rPr lang="en-US"/>
               <a:t>Second level</a:t>
             </a:r>
           </a:p>
           <a:p>
             <a:pPr lvl="2"/>
             <a:r>
-              <a:rPr lang="en-US" smtClean="0"/>
+              <a:rPr lang="en-US"/>
               <a:t>Third level</a:t>
             </a:r>
           </a:p>
           <a:p>
             <a:pPr lvl="3"/>
             <a:r>
-              <a:rPr lang="en-US" smtClean="0"/>
+              <a:rPr lang="en-US"/>
               <a:t>Fourth level</a:t>
             </a:r>
           </a:p>
           <a:p>
             <a:pPr lvl="4"/>
             <a:r>
-              <a:rPr lang="en-US" smtClean="0"/>
+              <a:rPr lang="en-US"/>
               <a:t>Fifth level</a:t>
             </a:r>
-            <a:endParaRPr lang="en-US"/>
           </a:p>
         </p:txBody>
       </p:sp>
@@ -816,7 +853,7 @@
           <a:p>
             <a:fld id="{5BCAD085-E8A6-8845-BD4E-CB4CCA059FC4}" type="datetimeFigureOut">
               <a:rPr lang="en-US" smtClean="0"/>
-              <a:t>1/27/13</a:t>
+              <a:t>7/9/2026</a:t>
             </a:fld>
             <a:endParaRPr lang="en-US"/>
           </a:p>
@@ -919,10 +956,9 @@
           </a:lstStyle>
           <a:p>
             <a:r>
-              <a:rPr lang="en-US" smtClean="0"/>
+              <a:rPr lang="en-US"/>
               <a:t>Click to edit Master title style</a:t>
             </a:r>
-            <a:endParaRPr lang="en-US"/>
           </a:p>
         </p:txBody>
       </p:sp>
@@ -1039,7 +1075,7 @@
           <a:p>
             <a:pPr lvl="0"/>
             <a:r>
-              <a:rPr lang="en-US" smtClean="0"/>
+              <a:rPr lang="en-US"/>
               <a:t>Click to edit Master text styles</a:t>
             </a:r>
           </a:p>
@@ -1062,7 +1098,7 @@
           <a:p>
             <a:fld id="{5BCAD085-E8A6-8845-BD4E-CB4CCA059FC4}" type="datetimeFigureOut">
               <a:rPr lang="en-US" smtClean="0"/>
-              <a:t>1/27/13</a:t>
+              <a:t>7/9/2026</a:t>
             </a:fld>
             <a:endParaRPr lang="en-US"/>
           </a:p>
@@ -1156,10 +1192,9 @@
           <a:lstStyle/>
           <a:p>
             <a:r>
-              <a:rPr lang="en-US" smtClean="0"/>
+              <a:rPr lang="en-US"/>
               <a:t>Click to edit Master title style</a:t>
             </a:r>
-            <a:endParaRPr lang="en-US"/>
           </a:p>
         </p:txBody>
       </p:sp>
@@ -1213,38 +1248,37 @@
           <a:p>
             <a:pPr lvl="0"/>
             <a:r>
-              <a:rPr lang="en-US" smtClean="0"/>
+              <a:rPr lang="en-US"/>
               <a:t>Click to edit Master text styles</a:t>
             </a:r>
           </a:p>
           <a:p>
             <a:pPr lvl="1"/>
             <a:r>
-              <a:rPr lang="en-US" smtClean="0"/>
+              <a:rPr lang="en-US"/>
               <a:t>Second level</a:t>
             </a:r>
           </a:p>
           <a:p>
             <a:pPr lvl="2"/>
             <a:r>
-              <a:rPr lang="en-US" smtClean="0"/>
+              <a:rPr lang="en-US"/>
               <a:t>Third level</a:t>
             </a:r>
           </a:p>
           <a:p>
             <a:pPr lvl="3"/>
             <a:r>
-              <a:rPr lang="en-US" smtClean="0"/>
+              <a:rPr lang="en-US"/>
               <a:t>Fourth level</a:t>
             </a:r>
           </a:p>
           <a:p>
             <a:pPr lvl="4"/>
             <a:r>
-              <a:rPr lang="en-US" smtClean="0"/>
+              <a:rPr lang="en-US"/>
               <a:t>Fifth level</a:t>
             </a:r>
-            <a:endParaRPr lang="en-US"/>
           </a:p>
         </p:txBody>
       </p:sp>
@@ -1298,38 +1332,37 @@
           <a:p>
             <a:pPr lvl="0"/>
             <a:r>
-              <a:rPr lang="en-US" smtClean="0"/>
+              <a:rPr lang="en-US"/>
               <a:t>Click to edit Master text styles</a:t>
             </a:r>
           </a:p>
           <a:p>
             <a:pPr lvl="1"/>
             <a:r>
-              <a:rPr lang="en-US" smtClean="0"/>
+              <a:rPr lang="en-US"/>
               <a:t>Second level</a:t>
             </a:r>
           </a:p>
           <a:p>
             <a:pPr lvl="2"/>
             <a:r>
-              <a:rPr lang="en-US" smtClean="0"/>
+              <a:rPr lang="en-US"/>
               <a:t>Third level</a:t>
             </a:r>
           </a:p>
           <a:p>
             <a:pPr lvl="3"/>
             <a:r>
-              <a:rPr lang="en-US" smtClean="0"/>
+              <a:rPr lang="en-US"/>
               <a:t>Fourth level</a:t>
             </a:r>
           </a:p>
           <a:p>
             <a:pPr lvl="4"/>
             <a:r>
-              <a:rPr lang="en-US" smtClean="0"/>
+              <a:rPr lang="en-US"/>
               <a:t>Fifth level</a:t>
             </a:r>
-            <a:endParaRPr lang="en-US"/>
           </a:p>
         </p:txBody>
       </p:sp>
@@ -1350,7 +1383,7 @@
           <a:p>
             <a:fld id="{5BCAD085-E8A6-8845-BD4E-CB4CCA059FC4}" type="datetimeFigureOut">
               <a:rPr lang="en-US" smtClean="0"/>
-              <a:t>1/27/13</a:t>
+              <a:t>7/9/2026</a:t>
             </a:fld>
             <a:endParaRPr lang="en-US"/>
           </a:p>
@@ -1448,10 +1481,9 @@
           </a:lstStyle>
           <a:p>
             <a:r>
-              <a:rPr lang="en-US" smtClean="0"/>
+              <a:rPr lang="en-US"/>
               <a:t>Click to edit Master title style</a:t>
             </a:r>
-            <a:endParaRPr lang="en-US"/>
           </a:p>
         </p:txBody>
       </p:sp>
@@ -1514,7 +1546,7 @@
           <a:p>
             <a:pPr lvl="0"/>
             <a:r>
-              <a:rPr lang="en-US" smtClean="0"/>
+              <a:rPr lang="en-US"/>
               <a:t>Click to edit Master text styles</a:t>
             </a:r>
           </a:p>
@@ -1570,38 +1602,37 @@
           <a:p>
             <a:pPr lvl="0"/>
             <a:r>
-              <a:rPr lang="en-US" smtClean="0"/>
+              <a:rPr lang="en-US"/>
               <a:t>Click to edit Master text styles</a:t>
             </a:r>
           </a:p>
           <a:p>
             <a:pPr lvl="1"/>
             <a:r>
-              <a:rPr lang="en-US" smtClean="0"/>
+              <a:rPr lang="en-US"/>
               <a:t>Second level</a:t>
             </a:r>
           </a:p>
           <a:p>
             <a:pPr lvl="2"/>
             <a:r>
-              <a:rPr lang="en-US" smtClean="0"/>
+              <a:rPr lang="en-US"/>
               <a:t>Third level</a:t>
             </a:r>
           </a:p>
           <a:p>
             <a:pPr lvl="3"/>
             <a:r>
-              <a:rPr lang="en-US" smtClean="0"/>
+              <a:rPr lang="en-US"/>
               <a:t>Fourth level</a:t>
             </a:r>
           </a:p>
           <a:p>
             <a:pPr lvl="4"/>
             <a:r>
-              <a:rPr lang="en-US" smtClean="0"/>
+              <a:rPr lang="en-US"/>
               <a:t>Fifth level</a:t>
             </a:r>
-            <a:endParaRPr lang="en-US"/>
           </a:p>
         </p:txBody>
       </p:sp>
@@ -1664,7 +1695,7 @@
           <a:p>
             <a:pPr lvl="0"/>
             <a:r>
-              <a:rPr lang="en-US" smtClean="0"/>
+              <a:rPr lang="en-US"/>
               <a:t>Click to edit Master text styles</a:t>
             </a:r>
           </a:p>
@@ -1720,38 +1751,37 @@
           <a:p>
             <a:pPr lvl="0"/>
             <a:r>
-              <a:rPr lang="en-US" smtClean="0"/>
+              <a:rPr lang="en-US"/>
               <a:t>Click to edit Master text styles</a:t>
             </a:r>
           </a:p>
           <a:p>
             <a:pPr lvl="1"/>
             <a:r>
-              <a:rPr lang="en-US" smtClean="0"/>
+              <a:rPr lang="en-US"/>
               <a:t>Second level</a:t>
             </a:r>
           </a:p>
           <a:p>
             <a:pPr lvl="2"/>
             <a:r>
-              <a:rPr lang="en-US" smtClean="0"/>
+              <a:rPr lang="en-US"/>
               <a:t>Third level</a:t>
             </a:r>
           </a:p>
           <a:p>
             <a:pPr lvl="3"/>
             <a:r>
-              <a:rPr lang="en-US" smtClean="0"/>
+              <a:rPr lang="en-US"/>
               <a:t>Fourth level</a:t>
             </a:r>
           </a:p>
           <a:p>
             <a:pPr lvl="4"/>
             <a:r>
-              <a:rPr lang="en-US" smtClean="0"/>
+              <a:rPr lang="en-US"/>
               <a:t>Fifth level</a:t>
             </a:r>
-            <a:endParaRPr lang="en-US"/>
           </a:p>
         </p:txBody>
       </p:sp>
@@ -1772,7 +1802,7 @@
           <a:p>
             <a:fld id="{5BCAD085-E8A6-8845-BD4E-CB4CCA059FC4}" type="datetimeFigureOut">
               <a:rPr lang="en-US" smtClean="0"/>
-              <a:t>1/27/13</a:t>
+              <a:t>7/9/2026</a:t>
             </a:fld>
             <a:endParaRPr lang="en-US"/>
           </a:p>
@@ -1866,10 +1896,9 @@
           <a:lstStyle/>
           <a:p>
             <a:r>
-              <a:rPr lang="en-US" smtClean="0"/>
+              <a:rPr lang="en-US"/>
               <a:t>Click to edit Master title style</a:t>
             </a:r>
-            <a:endParaRPr lang="en-US"/>
           </a:p>
         </p:txBody>
       </p:sp>
@@ -1890,7 +1919,7 @@
           <a:p>
             <a:fld id="{5BCAD085-E8A6-8845-BD4E-CB4CCA059FC4}" type="datetimeFigureOut">
               <a:rPr lang="en-US" smtClean="0"/>
-              <a:t>1/27/13</a:t>
+              <a:t>7/9/2026</a:t>
             </a:fld>
             <a:endParaRPr lang="en-US"/>
           </a:p>
@@ -1985,7 +2014,7 @@
           <a:p>
             <a:fld id="{5BCAD085-E8A6-8845-BD4E-CB4CCA059FC4}" type="datetimeFigureOut">
               <a:rPr lang="en-US" smtClean="0"/>
-              <a:t>1/27/13</a:t>
+              <a:t>7/9/2026</a:t>
             </a:fld>
             <a:endParaRPr lang="en-US"/>
           </a:p>
@@ -2088,10 +2117,9 @@
           </a:lstStyle>
           <a:p>
             <a:r>
-              <a:rPr lang="en-US" smtClean="0"/>
+              <a:rPr lang="en-US"/>
               <a:t>Click to edit Master title style</a:t>
             </a:r>
-            <a:endParaRPr lang="en-US"/>
           </a:p>
         </p:txBody>
       </p:sp>
@@ -2145,38 +2173,37 @@
           <a:p>
             <a:pPr lvl="0"/>
             <a:r>
-              <a:rPr lang="en-US" smtClean="0"/>
+              <a:rPr lang="en-US"/>
               <a:t>Click to edit Master text styles</a:t>
             </a:r>
           </a:p>
           <a:p>
             <a:pPr lvl="1"/>
             <a:r>
-              <a:rPr lang="en-US" smtClean="0"/>
+              <a:rPr lang="en-US"/>
               <a:t>Second level</a:t>
             </a:r>
           </a:p>
           <a:p>
             <a:pPr lvl="2"/>
             <a:r>
-              <a:rPr lang="en-US" smtClean="0"/>
+              <a:rPr lang="en-US"/>
               <a:t>Third level</a:t>
             </a:r>
           </a:p>
           <a:p>
             <a:pPr lvl="3"/>
             <a:r>
-              <a:rPr lang="en-US" smtClean="0"/>
+              <a:rPr lang="en-US"/>
               <a:t>Fourth level</a:t>
             </a:r>
           </a:p>
           <a:p>
             <a:pPr lvl="4"/>
             <a:r>
-              <a:rPr lang="en-US" smtClean="0"/>
+              <a:rPr lang="en-US"/>
               <a:t>Fifth level</a:t>
             </a:r>
-            <a:endParaRPr lang="en-US"/>
           </a:p>
         </p:txBody>
       </p:sp>
@@ -2239,7 +2266,7 @@
           <a:p>
             <a:pPr lvl="0"/>
             <a:r>
-              <a:rPr lang="en-US" smtClean="0"/>
+              <a:rPr lang="en-US"/>
               <a:t>Click to edit Master text styles</a:t>
             </a:r>
           </a:p>
@@ -2262,7 +2289,7 @@
           <a:p>
             <a:fld id="{5BCAD085-E8A6-8845-BD4E-CB4CCA059FC4}" type="datetimeFigureOut">
               <a:rPr lang="en-US" smtClean="0"/>
-              <a:t>1/27/13</a:t>
+              <a:t>7/9/2026</a:t>
             </a:fld>
             <a:endParaRPr lang="en-US"/>
           </a:p>
@@ -2365,10 +2392,9 @@
           </a:lstStyle>
           <a:p>
             <a:r>
-              <a:rPr lang="en-US" smtClean="0"/>
+              <a:rPr lang="en-US"/>
               <a:t>Click to edit Master title style</a:t>
             </a:r>
-            <a:endParaRPr lang="en-US"/>
           </a:p>
         </p:txBody>
       </p:sp>
@@ -2492,7 +2518,7 @@
           <a:p>
             <a:pPr lvl="0"/>
             <a:r>
-              <a:rPr lang="en-US" smtClean="0"/>
+              <a:rPr lang="en-US"/>
               <a:t>Click to edit Master text styles</a:t>
             </a:r>
           </a:p>
@@ -2515,7 +2541,7 @@
           <a:p>
             <a:fld id="{5BCAD085-E8A6-8845-BD4E-CB4CCA059FC4}" type="datetimeFigureOut">
               <a:rPr lang="en-US" smtClean="0"/>
-              <a:t>1/27/13</a:t>
+              <a:t>7/9/2026</a:t>
             </a:fld>
             <a:endParaRPr lang="en-US"/>
           </a:p>
@@ -2624,10 +2650,9 @@
           <a:lstStyle/>
           <a:p>
             <a:r>
-              <a:rPr lang="en-US" smtClean="0"/>
+              <a:rPr lang="en-US"/>
               <a:t>Click to edit Master title style</a:t>
             </a:r>
-            <a:endParaRPr lang="en-US"/>
           </a:p>
         </p:txBody>
       </p:sp>
@@ -2658,38 +2683,37 @@
           <a:p>
             <a:pPr lvl="0"/>
             <a:r>
-              <a:rPr lang="en-US" smtClean="0"/>
+              <a:rPr lang="en-US"/>
               <a:t>Click to edit Master text styles</a:t>
             </a:r>
           </a:p>
           <a:p>
             <a:pPr lvl="1"/>
             <a:r>
-              <a:rPr lang="en-US" smtClean="0"/>
+              <a:rPr lang="en-US"/>
               <a:t>Second level</a:t>
             </a:r>
           </a:p>
           <a:p>
             <a:pPr lvl="2"/>
             <a:r>
-              <a:rPr lang="en-US" smtClean="0"/>
+              <a:rPr lang="en-US"/>
               <a:t>Third level</a:t>
             </a:r>
           </a:p>
           <a:p>
             <a:pPr lvl="3"/>
             <a:r>
-              <a:rPr lang="en-US" smtClean="0"/>
+              <a:rPr lang="en-US"/>
               <a:t>Fourth level</a:t>
             </a:r>
           </a:p>
           <a:p>
             <a:pPr lvl="4"/>
             <a:r>
-              <a:rPr lang="en-US" smtClean="0"/>
+              <a:rPr lang="en-US"/>
               <a:t>Fifth level</a:t>
             </a:r>
-            <a:endParaRPr lang="en-US"/>
           </a:p>
         </p:txBody>
       </p:sp>
@@ -2728,7 +2752,7 @@
           <a:p>
             <a:fld id="{5BCAD085-E8A6-8845-BD4E-CB4CCA059FC4}" type="datetimeFigureOut">
               <a:rPr lang="en-US" smtClean="0"/>
-              <a:t>1/27/13</a:t>
+              <a:t>7/9/2026</a:t>
             </a:fld>
             <a:endParaRPr lang="en-US"/>
           </a:p>
@@ -3087,7 +3111,7 @@
 </file>
 
 <file path=ppt/slides/slide1.xml><?xml version="1.0" encoding="utf-8"?>
-<p:sld xmlns:a="http://schemas.openxmlformats.org/drawingml/2006/main" xmlns:p="http://schemas.openxmlformats.org/presentationml/2006/main" xmlns:r="http://schemas.openxmlformats.org/officeDocument/2006/relationships">
+<p:sld xmlns:a="http://schemas.openxmlformats.org/drawingml/2006/main" xmlns:r="http://schemas.openxmlformats.org/officeDocument/2006/relationships" xmlns:p="http://schemas.openxmlformats.org/presentationml/2006/main">
   <p:cSld>
     <p:bg>
       <p:bgPr>
@@ -3103,7 +3127,14 @@
         <p:cNvGrpSpPr/>
         <p:nvPr/>
       </p:nvGrpSpPr>
-      <p:grpSpPr/>
+      <p:grpSpPr>
+        <a:xfrm>
+          <a:off x="0" y="0"/>
+          <a:ext cx="0" cy="0"/>
+          <a:chOff x="0" y="0"/>
+          <a:chExt cx="0" cy="0"/>
+        </a:xfrm>
+      </p:grpSpPr>
       <p:sp>
         <p:nvSpPr>
           <p:cNvPr id="2" name="Rectangle 1"/>
@@ -3144,6 +3175,7 @@
           <a:lstStyle/>
           <a:p>
             <a:pPr algn="ctr"/>
+            <a:endParaRPr/>
           </a:p>
         </p:txBody>
       </p:sp>
@@ -3178,7 +3210,28 @@
               </a:defRPr>
             </a:pPr>
             <a:r>
-              <a:t>جسر القدس القانوني (JLM Legal Bridge)</a:t>
+              <a:rPr dirty="0" err="1"/>
+              <a:t>جسر</a:t>
+            </a:r>
+            <a:r>
+              <a:rPr dirty="0"/>
+              <a:t> </a:t>
+            </a:r>
+            <a:r>
+              <a:rPr dirty="0" err="1"/>
+              <a:t>القدس</a:t>
+            </a:r>
+            <a:r>
+              <a:rPr dirty="0"/>
+              <a:t> </a:t>
+            </a:r>
+            <a:r>
+              <a:rPr dirty="0" err="1"/>
+              <a:t>القانوني</a:t>
+            </a:r>
+            <a:r>
+              <a:rPr dirty="0"/>
+              <a:t> (JLM Legal Bridge)</a:t>
             </a:r>
           </a:p>
           <a:p>
@@ -3194,8 +3247,82 @@
               </a:defRPr>
             </a:pPr>
             <a:r>
-              <a:t>منصة استبيان رقمية ذكية ومتوافقة ثقافياً للعمال في القدس الشرقية</a:t>
-            </a:r>
+              <a:rPr dirty="0" err="1"/>
+              <a:t>منصة</a:t>
+            </a:r>
+            <a:r>
+              <a:rPr dirty="0"/>
+              <a:t> </a:t>
+            </a:r>
+            <a:r>
+              <a:rPr dirty="0" err="1"/>
+              <a:t>استبيان</a:t>
+            </a:r>
+            <a:r>
+              <a:rPr dirty="0"/>
+              <a:t> </a:t>
+            </a:r>
+            <a:r>
+              <a:rPr dirty="0" err="1"/>
+              <a:t>رقمية</a:t>
+            </a:r>
+            <a:r>
+              <a:rPr dirty="0"/>
+              <a:t> </a:t>
+            </a:r>
+            <a:r>
+              <a:rPr dirty="0" err="1"/>
+              <a:t>ذكية</a:t>
+            </a:r>
+            <a:r>
+              <a:rPr dirty="0"/>
+              <a:t> </a:t>
+            </a:r>
+            <a:r>
+              <a:rPr dirty="0" err="1"/>
+              <a:t>ومتوافقة</a:t>
+            </a:r>
+            <a:r>
+              <a:rPr dirty="0"/>
+              <a:t> </a:t>
+            </a:r>
+            <a:r>
+              <a:rPr dirty="0" err="1"/>
+              <a:t>ثقافياً</a:t>
+            </a:r>
+            <a:r>
+              <a:rPr dirty="0"/>
+              <a:t> </a:t>
+            </a:r>
+            <a:r>
+              <a:rPr dirty="0" err="1"/>
+              <a:t>للعمال</a:t>
+            </a:r>
+            <a:r>
+              <a:rPr dirty="0"/>
+              <a:t> </a:t>
+            </a:r>
+            <a:r>
+              <a:rPr dirty="0" err="1"/>
+              <a:t>في</a:t>
+            </a:r>
+            <a:r>
+              <a:rPr dirty="0"/>
+              <a:t> </a:t>
+            </a:r>
+            <a:r>
+              <a:rPr dirty="0" err="1"/>
+              <a:t>القدس</a:t>
+            </a:r>
+            <a:r>
+              <a:rPr dirty="0"/>
+              <a:t> </a:t>
+            </a:r>
+            <a:r>
+              <a:rPr dirty="0" err="1"/>
+              <a:t>الشرقية</a:t>
+            </a:r>
+            <a:endParaRPr dirty="0"/>
           </a:p>
         </p:txBody>
       </p:sp>
@@ -3208,7 +3335,7 @@
         <p:spPr>
           <a:xfrm>
             <a:off x="1371600" y="4389120"/>
-            <a:ext cx="9445752" cy="1828800"/>
+            <a:ext cx="9445752" cy="892552"/>
           </a:xfrm>
           <a:prstGeom prst="rect">
             <a:avLst/>
@@ -3233,7 +3360,56 @@
               </a:defRPr>
             </a:pPr>
             <a:r>
-              <a:t>مشروع التخرج في مساق إدارة المنتجات 2026</a:t>
+              <a:rPr lang="ar-SA" dirty="0"/>
+              <a:t> </a:t>
+            </a:r>
+            <a:r>
+              <a:rPr dirty="0" err="1"/>
+              <a:t>مشروع</a:t>
+            </a:r>
+            <a:r>
+              <a:rPr dirty="0"/>
+              <a:t> </a:t>
+            </a:r>
+            <a:r>
+              <a:rPr dirty="0" err="1"/>
+              <a:t>التخرج</a:t>
+            </a:r>
+            <a:r>
+              <a:rPr dirty="0"/>
+              <a:t> </a:t>
+            </a:r>
+            <a:r>
+              <a:rPr dirty="0" err="1"/>
+              <a:t>في</a:t>
+            </a:r>
+            <a:r>
+              <a:rPr dirty="0"/>
+              <a:t> </a:t>
+            </a:r>
+            <a:r>
+              <a:rPr dirty="0" err="1"/>
+              <a:t>مساق</a:t>
+            </a:r>
+            <a:r>
+              <a:rPr dirty="0"/>
+              <a:t> </a:t>
+            </a:r>
+            <a:r>
+              <a:rPr dirty="0" err="1"/>
+              <a:t>إدارة</a:t>
+            </a:r>
+            <a:r>
+              <a:rPr dirty="0"/>
+              <a:t> </a:t>
+            </a:r>
+            <a:r>
+              <a:rPr dirty="0" err="1"/>
+              <a:t>المنتجات</a:t>
+            </a:r>
+            <a:r>
+              <a:rPr dirty="0"/>
+              <a:t> 2026</a:t>
             </a:r>
           </a:p>
           <a:p>
@@ -3249,7 +3425,28 @@
               </a:defRPr>
             </a:pPr>
             <a:r>
-              <a:t>الكلية الأكاديمية أونو (OAC)</a:t>
+              <a:rPr dirty="0" err="1"/>
+              <a:t>الكلية</a:t>
+            </a:r>
+            <a:r>
+              <a:rPr dirty="0"/>
+              <a:t> </a:t>
+            </a:r>
+            <a:r>
+              <a:rPr dirty="0" err="1"/>
+              <a:t>الأكاديمية</a:t>
+            </a:r>
+            <a:r>
+              <a:rPr dirty="0"/>
+              <a:t> </a:t>
+            </a:r>
+            <a:r>
+              <a:rPr dirty="0" err="1"/>
+              <a:t>أونو</a:t>
+            </a:r>
+            <a:r>
+              <a:rPr dirty="0"/>
+              <a:t> (OAC)</a:t>
             </a:r>
           </a:p>
           <a:p>
@@ -3265,8 +3462,42 @@
               </a:defRPr>
             </a:pPr>
             <a:r>
-              <a:t>تقديم: فريق مشروع جسر القدس</a:t>
-            </a:r>
+              <a:rPr dirty="0" err="1"/>
+              <a:t>تقديم</a:t>
+            </a:r>
+            <a:r>
+              <a:rPr dirty="0"/>
+              <a:t>: </a:t>
+            </a:r>
+            <a:r>
+              <a:rPr dirty="0" err="1"/>
+              <a:t>فريق</a:t>
+            </a:r>
+            <a:r>
+              <a:rPr dirty="0"/>
+              <a:t> </a:t>
+            </a:r>
+            <a:r>
+              <a:rPr dirty="0" err="1"/>
+              <a:t>مشروع</a:t>
+            </a:r>
+            <a:r>
+              <a:rPr dirty="0"/>
+              <a:t> </a:t>
+            </a:r>
+            <a:r>
+              <a:rPr dirty="0" err="1"/>
+              <a:t>جسر</a:t>
+            </a:r>
+            <a:r>
+              <a:rPr dirty="0"/>
+              <a:t> </a:t>
+            </a:r>
+            <a:r>
+              <a:rPr dirty="0" err="1"/>
+              <a:t>القدس</a:t>
+            </a:r>
+            <a:endParaRPr dirty="0"/>
           </a:p>
         </p:txBody>
       </p:sp>
@@ -3279,7 +3510,7 @@
 </file>
 
 <file path=ppt/slides/slide2.xml><?xml version="1.0" encoding="utf-8"?>
-<p:sld xmlns:a="http://schemas.openxmlformats.org/drawingml/2006/main" xmlns:p="http://schemas.openxmlformats.org/presentationml/2006/main" xmlns:r="http://schemas.openxmlformats.org/officeDocument/2006/relationships">
+<p:sld xmlns:a="http://schemas.openxmlformats.org/drawingml/2006/main" xmlns:r="http://schemas.openxmlformats.org/officeDocument/2006/relationships" xmlns:p="http://schemas.openxmlformats.org/presentationml/2006/main">
   <p:cSld>
     <p:bg>
       <p:bgPr>
@@ -3295,7 +3526,14 @@
         <p:cNvGrpSpPr/>
         <p:nvPr/>
       </p:nvGrpSpPr>
-      <p:grpSpPr/>
+      <p:grpSpPr>
+        <a:xfrm>
+          <a:off x="0" y="0"/>
+          <a:ext cx="0" cy="0"/>
+          <a:chOff x="0" y="0"/>
+          <a:chExt cx="0" cy="0"/>
+        </a:xfrm>
+      </p:grpSpPr>
       <p:sp>
         <p:nvSpPr>
           <p:cNvPr id="2" name="TextBox 1"/>
@@ -3402,7 +3640,124 @@
               </a:defRPr>
             </a:pPr>
             <a:r>
-              <a:t>المشكلة الرئيسية: عوائق حاسمة في الوصول إلى العدالة ونيل التعويضات الطبية لعمال القدس الشرقية المصابين.</a:t>
+              <a:rPr dirty="0" err="1"/>
+              <a:t>المشكلة</a:t>
+            </a:r>
+            <a:r>
+              <a:rPr dirty="0"/>
+              <a:t> </a:t>
+            </a:r>
+            <a:r>
+              <a:rPr dirty="0" err="1"/>
+              <a:t>الرئيسية</a:t>
+            </a:r>
+            <a:r>
+              <a:rPr dirty="0"/>
+              <a:t>: </a:t>
+            </a:r>
+            <a:r>
+              <a:rPr dirty="0" err="1"/>
+              <a:t>عوائق</a:t>
+            </a:r>
+            <a:r>
+              <a:rPr dirty="0"/>
+              <a:t> </a:t>
+            </a:r>
+            <a:r>
+              <a:rPr dirty="0" err="1"/>
+              <a:t>حاسمة</a:t>
+            </a:r>
+            <a:r>
+              <a:rPr dirty="0"/>
+              <a:t> </a:t>
+            </a:r>
+            <a:r>
+              <a:rPr dirty="0" err="1"/>
+              <a:t>في</a:t>
+            </a:r>
+            <a:r>
+              <a:rPr dirty="0"/>
+              <a:t> </a:t>
+            </a:r>
+            <a:r>
+              <a:rPr dirty="0" err="1"/>
+              <a:t>الوصول</a:t>
+            </a:r>
+            <a:r>
+              <a:rPr dirty="0"/>
+              <a:t> </a:t>
+            </a:r>
+            <a:r>
+              <a:rPr dirty="0" err="1"/>
+              <a:t>إلى</a:t>
+            </a:r>
+            <a:r>
+              <a:rPr dirty="0"/>
+              <a:t> </a:t>
+            </a:r>
+            <a:r>
+              <a:rPr dirty="0" err="1"/>
+              <a:t>العدالة</a:t>
+            </a:r>
+            <a:r>
+              <a:rPr dirty="0"/>
+              <a:t> </a:t>
+            </a:r>
+            <a:r>
+              <a:rPr dirty="0" err="1"/>
+              <a:t>ونيل</a:t>
+            </a:r>
+            <a:r>
+              <a:rPr dirty="0"/>
+              <a:t> </a:t>
+            </a:r>
+            <a:r>
+              <a:rPr dirty="0" err="1"/>
+              <a:t>التعويضات</a:t>
+            </a:r>
+            <a:r>
+              <a:rPr dirty="0"/>
+              <a:t> </a:t>
+            </a:r>
+            <a:r>
+              <a:rPr dirty="0" err="1"/>
+              <a:t>الطبية</a:t>
+            </a:r>
+            <a:r>
+              <a:rPr dirty="0"/>
+              <a:t> </a:t>
+            </a:r>
+            <a:r>
+              <a:rPr dirty="0" err="1"/>
+              <a:t>لعمال</a:t>
+            </a:r>
+            <a:r>
+              <a:rPr dirty="0"/>
+              <a:t> </a:t>
+            </a:r>
+            <a:r>
+              <a:rPr dirty="0" err="1"/>
+              <a:t>القدس</a:t>
+            </a:r>
+            <a:r>
+              <a:rPr dirty="0"/>
+              <a:t> </a:t>
+            </a:r>
+            <a:r>
+              <a:rPr dirty="0" err="1"/>
+              <a:t>الشرقية</a:t>
+            </a:r>
+            <a:r>
+              <a:rPr dirty="0"/>
+              <a:t> </a:t>
+            </a:r>
+            <a:r>
+              <a:rPr dirty="0" err="1"/>
+              <a:t>المصابين</a:t>
+            </a:r>
+            <a:r>
+              <a:rPr dirty="0"/>
+              <a:t>.</a:t>
             </a:r>
           </a:p>
           <a:p>
@@ -3418,7 +3773,44 @@
               </a:defRPr>
             </a:pPr>
             <a:r>
-              <a:t>نقاط الألم الرئيسية في السوق:</a:t>
+              <a:rPr dirty="0" err="1"/>
+              <a:t>نقاط</a:t>
+            </a:r>
+            <a:r>
+              <a:rPr dirty="0"/>
+              <a:t> </a:t>
+            </a:r>
+            <a:r>
+              <a:rPr dirty="0" err="1"/>
+              <a:t>الألم</a:t>
+            </a:r>
+            <a:r>
+              <a:rPr dirty="0"/>
+              <a:t> </a:t>
+            </a:r>
+            <a:r>
+              <a:rPr dirty="0" err="1"/>
+              <a:t>الرئيسية</a:t>
+            </a:r>
+            <a:r>
+              <a:rPr dirty="0"/>
+              <a:t> </a:t>
+            </a:r>
+            <a:r>
+              <a:rPr dirty="0" err="1"/>
+              <a:t>في</a:t>
+            </a:r>
+            <a:r>
+              <a:rPr dirty="0"/>
+              <a:t> </a:t>
+            </a:r>
+            <a:r>
+              <a:rPr dirty="0" err="1"/>
+              <a:t>السوق</a:t>
+            </a:r>
+            <a:r>
+              <a:rPr dirty="0"/>
+              <a:t>:</a:t>
             </a:r>
           </a:p>
           <a:p>
@@ -3434,7 +3826,92 @@
               </a:defRPr>
             </a:pPr>
             <a:r>
-              <a:t>الخوف المالي: خوف العمال المستمر من تكاليف الاستشارة القانونية المرتفعة مسبقاً.</a:t>
+              <a:rPr dirty="0" err="1"/>
+              <a:t>الخوف</a:t>
+            </a:r>
+            <a:r>
+              <a:rPr dirty="0"/>
+              <a:t> </a:t>
+            </a:r>
+            <a:r>
+              <a:rPr dirty="0" err="1"/>
+              <a:t>المالي</a:t>
+            </a:r>
+            <a:r>
+              <a:rPr dirty="0"/>
+              <a:t>: </a:t>
+            </a:r>
+            <a:r>
+              <a:rPr dirty="0" err="1"/>
+              <a:t>خوف</a:t>
+            </a:r>
+            <a:r>
+              <a:rPr dirty="0"/>
+              <a:t> </a:t>
+            </a:r>
+            <a:r>
+              <a:rPr dirty="0" err="1"/>
+              <a:t>العمال</a:t>
+            </a:r>
+            <a:r>
+              <a:rPr dirty="0"/>
+              <a:t> </a:t>
+            </a:r>
+            <a:r>
+              <a:rPr dirty="0" err="1"/>
+              <a:t>المستمر</a:t>
+            </a:r>
+            <a:r>
+              <a:rPr dirty="0"/>
+              <a:t> </a:t>
+            </a:r>
+            <a:r>
+              <a:rPr dirty="0" err="1"/>
+              <a:t>من</a:t>
+            </a:r>
+            <a:r>
+              <a:rPr dirty="0"/>
+              <a:t> </a:t>
+            </a:r>
+            <a:r>
+              <a:rPr dirty="0" err="1"/>
+              <a:t>تكاليف</a:t>
+            </a:r>
+            <a:r>
+              <a:rPr dirty="0"/>
+              <a:t> </a:t>
+            </a:r>
+            <a:r>
+              <a:rPr dirty="0" err="1"/>
+              <a:t>الاستشارة</a:t>
+            </a:r>
+            <a:r>
+              <a:rPr dirty="0"/>
+              <a:t> </a:t>
+            </a:r>
+            <a:r>
+              <a:rPr dirty="0" err="1"/>
+              <a:t>القانونية</a:t>
+            </a:r>
+            <a:r>
+              <a:rPr dirty="0"/>
+              <a:t> </a:t>
+            </a:r>
+            <a:r>
+              <a:rPr dirty="0" err="1"/>
+              <a:t>المرتفعة</a:t>
+            </a:r>
+            <a:r>
+              <a:rPr dirty="0"/>
+              <a:t> </a:t>
+            </a:r>
+            <a:r>
+              <a:rPr dirty="0" err="1"/>
+              <a:t>مسبقاً</a:t>
+            </a:r>
+            <a:r>
+              <a:rPr dirty="0"/>
+              <a:t>.</a:t>
             </a:r>
           </a:p>
           <a:p>
@@ -3450,7 +3927,92 @@
               </a:defRPr>
             </a:pPr>
             <a:r>
-              <a:t>حاجز اللغة والثقافة: القوانين والمعلومات مكتوبة باللغة العبرية القانونية المعقدة فقط.</a:t>
+              <a:rPr dirty="0" err="1"/>
+              <a:t>حاجز</a:t>
+            </a:r>
+            <a:r>
+              <a:rPr dirty="0"/>
+              <a:t> </a:t>
+            </a:r>
+            <a:r>
+              <a:rPr dirty="0" err="1"/>
+              <a:t>اللغة</a:t>
+            </a:r>
+            <a:r>
+              <a:rPr dirty="0"/>
+              <a:t> </a:t>
+            </a:r>
+            <a:r>
+              <a:rPr dirty="0" err="1"/>
+              <a:t>والثقافة</a:t>
+            </a:r>
+            <a:r>
+              <a:rPr dirty="0"/>
+              <a:t>: </a:t>
+            </a:r>
+            <a:r>
+              <a:rPr dirty="0" err="1"/>
+              <a:t>القوانين</a:t>
+            </a:r>
+            <a:r>
+              <a:rPr dirty="0"/>
+              <a:t> </a:t>
+            </a:r>
+            <a:r>
+              <a:rPr dirty="0" err="1"/>
+              <a:t>والمعلومات</a:t>
+            </a:r>
+            <a:r>
+              <a:rPr dirty="0"/>
+              <a:t> </a:t>
+            </a:r>
+            <a:r>
+              <a:rPr dirty="0" err="1"/>
+              <a:t>مكتوبة</a:t>
+            </a:r>
+            <a:r>
+              <a:rPr dirty="0"/>
+              <a:t> </a:t>
+            </a:r>
+            <a:r>
+              <a:rPr dirty="0" err="1"/>
+              <a:t>باللغة</a:t>
+            </a:r>
+            <a:r>
+              <a:rPr dirty="0"/>
+              <a:t> </a:t>
+            </a:r>
+            <a:r>
+              <a:rPr dirty="0" err="1"/>
+              <a:t>العبرية</a:t>
+            </a:r>
+            <a:r>
+              <a:rPr dirty="0"/>
+              <a:t> </a:t>
+            </a:r>
+            <a:r>
+              <a:rPr dirty="0" err="1"/>
+              <a:t>القانونية</a:t>
+            </a:r>
+            <a:r>
+              <a:rPr dirty="0"/>
+              <a:t> </a:t>
+            </a:r>
+            <a:r>
+              <a:rPr dirty="0" err="1"/>
+              <a:t>المعقدة</a:t>
+            </a:r>
+            <a:r>
+              <a:rPr dirty="0"/>
+              <a:t> </a:t>
+            </a:r>
+            <a:r>
+              <a:rPr dirty="0" err="1"/>
+              <a:t>فقط</a:t>
+            </a:r>
+            <a:r>
+              <a:rPr dirty="0"/>
+              <a:t>.</a:t>
             </a:r>
           </a:p>
           <a:p>
@@ -3466,7 +4028,116 @@
               </a:defRPr>
             </a:pPr>
             <a:r>
-              <a:t>الخوف الشخصي والوظيفي: خوف الفلاحين والعمال من الفصل أو التعرض للمضايقات عند رفع قضية.</a:t>
+              <a:rPr dirty="0" err="1"/>
+              <a:t>الخوف</a:t>
+            </a:r>
+            <a:r>
+              <a:rPr dirty="0"/>
+              <a:t> </a:t>
+            </a:r>
+            <a:r>
+              <a:rPr dirty="0" err="1"/>
+              <a:t>الشخصي</a:t>
+            </a:r>
+            <a:r>
+              <a:rPr dirty="0"/>
+              <a:t> </a:t>
+            </a:r>
+            <a:r>
+              <a:rPr dirty="0" err="1"/>
+              <a:t>والوظيفي</a:t>
+            </a:r>
+            <a:r>
+              <a:rPr dirty="0"/>
+              <a:t>: </a:t>
+            </a:r>
+            <a:r>
+              <a:rPr dirty="0" err="1"/>
+              <a:t>خوف</a:t>
+            </a:r>
+            <a:r>
+              <a:rPr dirty="0"/>
+              <a:t> </a:t>
+            </a:r>
+            <a:r>
+              <a:rPr dirty="0" err="1"/>
+              <a:t>الفلاحين</a:t>
+            </a:r>
+            <a:r>
+              <a:rPr dirty="0"/>
+              <a:t> </a:t>
+            </a:r>
+            <a:r>
+              <a:rPr dirty="0" err="1"/>
+              <a:t>والعمال</a:t>
+            </a:r>
+            <a:r>
+              <a:rPr dirty="0"/>
+              <a:t> </a:t>
+            </a:r>
+            <a:r>
+              <a:rPr dirty="0" err="1"/>
+              <a:t>من</a:t>
+            </a:r>
+            <a:r>
+              <a:rPr dirty="0"/>
+              <a:t> </a:t>
+            </a:r>
+            <a:r>
+              <a:rPr dirty="0" err="1"/>
+              <a:t>الفصل</a:t>
+            </a:r>
+            <a:r>
+              <a:rPr dirty="0"/>
+              <a:t> </a:t>
+            </a:r>
+            <a:r>
+              <a:rPr dirty="0" err="1"/>
+              <a:t>أو</a:t>
+            </a:r>
+            <a:r>
+              <a:rPr dirty="0"/>
+              <a:t> </a:t>
+            </a:r>
+            <a:r>
+              <a:rPr dirty="0" err="1"/>
+              <a:t>التعرض</a:t>
+            </a:r>
+            <a:r>
+              <a:rPr dirty="0"/>
+              <a:t> </a:t>
+            </a:r>
+            <a:r>
+              <a:rPr dirty="0" err="1"/>
+              <a:t>للمضايقات</a:t>
+            </a:r>
+            <a:r>
+              <a:rPr dirty="0"/>
+              <a:t> </a:t>
+            </a:r>
+            <a:r>
+              <a:rPr dirty="0" err="1"/>
+              <a:t>عند</a:t>
+            </a:r>
+            <a:r>
+              <a:rPr dirty="0"/>
+              <a:t> </a:t>
+            </a:r>
+            <a:r>
+              <a:rPr dirty="0" err="1"/>
+              <a:t>رفع</a:t>
+            </a:r>
+            <a:r>
+              <a:rPr dirty="0"/>
+              <a:t> </a:t>
+            </a:r>
+            <a:r>
+              <a:rPr dirty="0" err="1"/>
+              <a:t>قضية</a:t>
+            </a:r>
+            <a:r>
+              <a:rPr dirty="0"/>
+              <a:t>.</a:t>
             </a:r>
           </a:p>
           <a:p>
@@ -3482,7 +4153,100 @@
               </a:defRPr>
             </a:pPr>
             <a:r>
-              <a:t>التعقيد البيروقراطي: صعوبة جمع وفهم التقارير والمستندات الطبية المطلوبة بعد الإصابة مباشرة.</a:t>
+              <a:rPr dirty="0" err="1"/>
+              <a:t>التعقيد</a:t>
+            </a:r>
+            <a:r>
+              <a:rPr dirty="0"/>
+              <a:t> </a:t>
+            </a:r>
+            <a:r>
+              <a:rPr dirty="0" err="1"/>
+              <a:t>البيروقراطي</a:t>
+            </a:r>
+            <a:r>
+              <a:rPr dirty="0"/>
+              <a:t>: </a:t>
+            </a:r>
+            <a:r>
+              <a:rPr dirty="0" err="1"/>
+              <a:t>صعوبة</a:t>
+            </a:r>
+            <a:r>
+              <a:rPr dirty="0"/>
+              <a:t> </a:t>
+            </a:r>
+            <a:r>
+              <a:rPr dirty="0" err="1"/>
+              <a:t>جمع</a:t>
+            </a:r>
+            <a:r>
+              <a:rPr dirty="0"/>
+              <a:t> </a:t>
+            </a:r>
+            <a:r>
+              <a:rPr dirty="0" err="1"/>
+              <a:t>وفهم</a:t>
+            </a:r>
+            <a:r>
+              <a:rPr dirty="0"/>
+              <a:t> </a:t>
+            </a:r>
+            <a:r>
+              <a:rPr dirty="0" err="1"/>
+              <a:t>التقارير</a:t>
+            </a:r>
+            <a:r>
+              <a:rPr dirty="0"/>
+              <a:t> </a:t>
+            </a:r>
+            <a:r>
+              <a:rPr dirty="0" err="1"/>
+              <a:t>والمستندات</a:t>
+            </a:r>
+            <a:r>
+              <a:rPr dirty="0"/>
+              <a:t> </a:t>
+            </a:r>
+            <a:r>
+              <a:rPr dirty="0" err="1"/>
+              <a:t>الطبية</a:t>
+            </a:r>
+            <a:r>
+              <a:rPr dirty="0"/>
+              <a:t> </a:t>
+            </a:r>
+            <a:r>
+              <a:rPr dirty="0" err="1"/>
+              <a:t>المطلوبة</a:t>
+            </a:r>
+            <a:r>
+              <a:rPr dirty="0"/>
+              <a:t> </a:t>
+            </a:r>
+            <a:r>
+              <a:rPr dirty="0" err="1"/>
+              <a:t>بعد</a:t>
+            </a:r>
+            <a:r>
+              <a:rPr dirty="0"/>
+              <a:t> </a:t>
+            </a:r>
+            <a:r>
+              <a:rPr dirty="0" err="1"/>
+              <a:t>الإصابة</a:t>
+            </a:r>
+            <a:r>
+              <a:rPr dirty="0"/>
+              <a:t> </a:t>
+            </a:r>
+            <a:r>
+              <a:rPr dirty="0" err="1"/>
+              <a:t>مباشرة</a:t>
+            </a:r>
+            <a:r>
+              <a:rPr dirty="0"/>
+              <a:t>.</a:t>
             </a:r>
           </a:p>
           <a:p>
@@ -3498,7 +4262,68 @@
               </a:defRPr>
             </a:pPr>
             <a:r>
-              <a:t>الفرضيات الأساسية التي تم تبنيها في بداية المشروع (Hypotheses):</a:t>
+              <a:rPr dirty="0" err="1"/>
+              <a:t>الفرضيات</a:t>
+            </a:r>
+            <a:r>
+              <a:rPr dirty="0"/>
+              <a:t> </a:t>
+            </a:r>
+            <a:r>
+              <a:rPr dirty="0" err="1"/>
+              <a:t>الأساسية</a:t>
+            </a:r>
+            <a:r>
+              <a:rPr dirty="0"/>
+              <a:t> </a:t>
+            </a:r>
+            <a:r>
+              <a:rPr dirty="0" err="1"/>
+              <a:t>التي</a:t>
+            </a:r>
+            <a:r>
+              <a:rPr dirty="0"/>
+              <a:t> </a:t>
+            </a:r>
+            <a:r>
+              <a:rPr dirty="0" err="1"/>
+              <a:t>تم</a:t>
+            </a:r>
+            <a:r>
+              <a:rPr dirty="0"/>
+              <a:t> </a:t>
+            </a:r>
+            <a:r>
+              <a:rPr dirty="0" err="1"/>
+              <a:t>تبنيها</a:t>
+            </a:r>
+            <a:r>
+              <a:rPr dirty="0"/>
+              <a:t> </a:t>
+            </a:r>
+            <a:r>
+              <a:rPr dirty="0" err="1"/>
+              <a:t>في</a:t>
+            </a:r>
+            <a:r>
+              <a:rPr dirty="0"/>
+              <a:t> </a:t>
+            </a:r>
+            <a:r>
+              <a:rPr dirty="0" err="1"/>
+              <a:t>بداية</a:t>
+            </a:r>
+            <a:r>
+              <a:rPr dirty="0"/>
+              <a:t> </a:t>
+            </a:r>
+            <a:r>
+              <a:rPr dirty="0" err="1"/>
+              <a:t>المشروع</a:t>
+            </a:r>
+            <a:r>
+              <a:rPr dirty="0"/>
+              <a:t> (Hypotheses):</a:t>
             </a:r>
           </a:p>
           <a:p>
@@ -3514,7 +4339,108 @@
               </a:defRPr>
             </a:pPr>
             <a:r>
-              <a:t>فرضية القيمة (Value): توفير استبيان رقمي تفاعلي بلغة الأم ومجاناً سيزيد من التجاوب بنسبة 40%.</a:t>
+              <a:rPr dirty="0" err="1"/>
+              <a:t>فرضية</a:t>
+            </a:r>
+            <a:r>
+              <a:rPr dirty="0"/>
+              <a:t> </a:t>
+            </a:r>
+            <a:r>
+              <a:rPr dirty="0" err="1"/>
+              <a:t>القيمة</a:t>
+            </a:r>
+            <a:r>
+              <a:rPr dirty="0"/>
+              <a:t> (Value): </a:t>
+            </a:r>
+            <a:r>
+              <a:rPr dirty="0" err="1"/>
+              <a:t>توفير</a:t>
+            </a:r>
+            <a:r>
+              <a:rPr dirty="0"/>
+              <a:t> </a:t>
+            </a:r>
+            <a:r>
+              <a:rPr dirty="0" err="1"/>
+              <a:t>استبيان</a:t>
+            </a:r>
+            <a:r>
+              <a:rPr dirty="0"/>
+              <a:t> </a:t>
+            </a:r>
+            <a:r>
+              <a:rPr dirty="0" err="1"/>
+              <a:t>رقمي</a:t>
+            </a:r>
+            <a:r>
+              <a:rPr dirty="0"/>
+              <a:t> </a:t>
+            </a:r>
+            <a:r>
+              <a:rPr dirty="0" err="1"/>
+              <a:t>تفاعلي</a:t>
+            </a:r>
+            <a:r>
+              <a:rPr dirty="0"/>
+              <a:t> </a:t>
+            </a:r>
+            <a:r>
+              <a:rPr dirty="0" err="1"/>
+              <a:t>بلغة</a:t>
+            </a:r>
+            <a:r>
+              <a:rPr dirty="0"/>
+              <a:t> </a:t>
+            </a:r>
+            <a:r>
+              <a:rPr dirty="0" err="1"/>
+              <a:t>الأم</a:t>
+            </a:r>
+            <a:r>
+              <a:rPr dirty="0"/>
+              <a:t> </a:t>
+            </a:r>
+            <a:r>
+              <a:rPr dirty="0" err="1"/>
+              <a:t>ومجاناً</a:t>
+            </a:r>
+            <a:r>
+              <a:rPr dirty="0"/>
+              <a:t> </a:t>
+            </a:r>
+            <a:r>
+              <a:rPr dirty="0" err="1"/>
+              <a:t>سيزيد</a:t>
+            </a:r>
+            <a:r>
+              <a:rPr dirty="0"/>
+              <a:t> </a:t>
+            </a:r>
+            <a:r>
+              <a:rPr dirty="0" err="1"/>
+              <a:t>من</a:t>
+            </a:r>
+            <a:r>
+              <a:rPr dirty="0"/>
+              <a:t> </a:t>
+            </a:r>
+            <a:r>
+              <a:rPr dirty="0" err="1"/>
+              <a:t>التجاوب</a:t>
+            </a:r>
+            <a:r>
+              <a:rPr dirty="0"/>
+              <a:t> </a:t>
+            </a:r>
+            <a:r>
+              <a:rPr dirty="0" err="1"/>
+              <a:t>بنسبة</a:t>
+            </a:r>
+            <a:r>
+              <a:rPr dirty="0"/>
+              <a:t> 40%.</a:t>
             </a:r>
           </a:p>
           <a:p>
@@ -3530,7 +4456,92 @@
               </a:defRPr>
             </a:pPr>
             <a:r>
-              <a:t>فرضية سهولة الاستخدام (Usability): واجهة الإدخال والتسجيل الصوتي (Voice-to-Text) ستمنع الهجر وصعوبة الكتابة.</a:t>
+              <a:rPr dirty="0" err="1"/>
+              <a:t>فرضية</a:t>
+            </a:r>
+            <a:r>
+              <a:rPr dirty="0"/>
+              <a:t> </a:t>
+            </a:r>
+            <a:r>
+              <a:rPr dirty="0" err="1"/>
+              <a:t>سهولة</a:t>
+            </a:r>
+            <a:r>
+              <a:rPr dirty="0"/>
+              <a:t> </a:t>
+            </a:r>
+            <a:r>
+              <a:rPr dirty="0" err="1"/>
+              <a:t>الاستخدام</a:t>
+            </a:r>
+            <a:r>
+              <a:rPr dirty="0"/>
+              <a:t> (Usability): </a:t>
+            </a:r>
+            <a:r>
+              <a:rPr dirty="0" err="1"/>
+              <a:t>واجهة</a:t>
+            </a:r>
+            <a:r>
+              <a:rPr dirty="0"/>
+              <a:t> </a:t>
+            </a:r>
+            <a:r>
+              <a:rPr dirty="0" err="1"/>
+              <a:t>الإدخال</a:t>
+            </a:r>
+            <a:r>
+              <a:rPr dirty="0"/>
+              <a:t> </a:t>
+            </a:r>
+            <a:r>
+              <a:rPr dirty="0" err="1"/>
+              <a:t>والتسجيل</a:t>
+            </a:r>
+            <a:r>
+              <a:rPr dirty="0"/>
+              <a:t> </a:t>
+            </a:r>
+            <a:r>
+              <a:rPr dirty="0" err="1"/>
+              <a:t>الصوتي</a:t>
+            </a:r>
+            <a:r>
+              <a:rPr dirty="0"/>
+              <a:t> (Voice-to-Text) </a:t>
+            </a:r>
+            <a:r>
+              <a:rPr dirty="0" err="1"/>
+              <a:t>ستمنع</a:t>
+            </a:r>
+            <a:r>
+              <a:rPr dirty="0"/>
+              <a:t> </a:t>
+            </a:r>
+            <a:r>
+              <a:rPr dirty="0" err="1"/>
+              <a:t>الهجر</a:t>
+            </a:r>
+            <a:r>
+              <a:rPr dirty="0"/>
+              <a:t> </a:t>
+            </a:r>
+            <a:r>
+              <a:rPr dirty="0" err="1"/>
+              <a:t>وصعوبة</a:t>
+            </a:r>
+            <a:r>
+              <a:rPr dirty="0"/>
+              <a:t> </a:t>
+            </a:r>
+            <a:r>
+              <a:rPr dirty="0" err="1"/>
+              <a:t>الكتابة</a:t>
+            </a:r>
+            <a:r>
+              <a:rPr dirty="0"/>
+              <a:t>.</a:t>
             </a:r>
           </a:p>
           <a:p>
@@ -3546,7 +4557,100 @@
               </a:defRPr>
             </a:pPr>
             <a:r>
-              <a:t>فرضية البقاء التجاري (Viability): مبدأ 'الدفع عند النجاح فقط' (No Win = No Fee) سيزيل الخوف المالي تماماً.</a:t>
+              <a:rPr dirty="0" err="1"/>
+              <a:t>فرضية</a:t>
+            </a:r>
+            <a:r>
+              <a:rPr dirty="0"/>
+              <a:t> </a:t>
+            </a:r>
+            <a:r>
+              <a:rPr dirty="0" err="1"/>
+              <a:t>البقاء</a:t>
+            </a:r>
+            <a:r>
+              <a:rPr dirty="0"/>
+              <a:t> </a:t>
+            </a:r>
+            <a:r>
+              <a:rPr dirty="0" err="1"/>
+              <a:t>التجاري</a:t>
+            </a:r>
+            <a:r>
+              <a:rPr dirty="0"/>
+              <a:t> (Viability): </a:t>
+            </a:r>
+            <a:r>
+              <a:rPr dirty="0" err="1"/>
+              <a:t>مبدأ</a:t>
+            </a:r>
+            <a:r>
+              <a:rPr dirty="0"/>
+              <a:t> '</a:t>
+            </a:r>
+            <a:r>
+              <a:rPr dirty="0" err="1"/>
+              <a:t>الدفع</a:t>
+            </a:r>
+            <a:r>
+              <a:rPr dirty="0"/>
+              <a:t> </a:t>
+            </a:r>
+            <a:r>
+              <a:rPr dirty="0" err="1"/>
+              <a:t>عند</a:t>
+            </a:r>
+            <a:r>
+              <a:rPr dirty="0"/>
+              <a:t> </a:t>
+            </a:r>
+            <a:r>
+              <a:rPr dirty="0" err="1"/>
+              <a:t>النجاح</a:t>
+            </a:r>
+            <a:r>
+              <a:rPr dirty="0"/>
+              <a:t> </a:t>
+            </a:r>
+            <a:r>
+              <a:rPr dirty="0" err="1"/>
+              <a:t>فقط</a:t>
+            </a:r>
+            <a:r>
+              <a:rPr dirty="0"/>
+              <a:t>' (No Win = No Fee) </a:t>
+            </a:r>
+            <a:r>
+              <a:rPr dirty="0" err="1"/>
+              <a:t>سيزيل</a:t>
+            </a:r>
+            <a:r>
+              <a:rPr dirty="0"/>
+              <a:t> </a:t>
+            </a:r>
+            <a:r>
+              <a:rPr dirty="0" err="1"/>
+              <a:t>الخوف</a:t>
+            </a:r>
+            <a:r>
+              <a:rPr dirty="0"/>
+              <a:t> </a:t>
+            </a:r>
+            <a:r>
+              <a:rPr dirty="0" err="1"/>
+              <a:t>المالي</a:t>
+            </a:r>
+            <a:r>
+              <a:rPr dirty="0"/>
+              <a:t> </a:t>
+            </a:r>
+            <a:r>
+              <a:rPr dirty="0" err="1"/>
+              <a:t>تماماً</a:t>
+            </a:r>
+            <a:r>
+              <a:rPr dirty="0"/>
+              <a:t>.</a:t>
             </a:r>
           </a:p>
         </p:txBody>
@@ -3560,7 +4664,7 @@
 </file>
 
 <file path=ppt/slides/slide3.xml><?xml version="1.0" encoding="utf-8"?>
-<p:sld xmlns:a="http://schemas.openxmlformats.org/drawingml/2006/main" xmlns:p="http://schemas.openxmlformats.org/presentationml/2006/main" xmlns:r="http://schemas.openxmlformats.org/officeDocument/2006/relationships">
+<p:sld xmlns:a="http://schemas.openxmlformats.org/drawingml/2006/main" xmlns:r="http://schemas.openxmlformats.org/officeDocument/2006/relationships" xmlns:p="http://schemas.openxmlformats.org/presentationml/2006/main">
   <p:cSld>
     <p:bg>
       <p:bgPr>
@@ -3576,7 +4680,14 @@
         <p:cNvGrpSpPr/>
         <p:nvPr/>
       </p:nvGrpSpPr>
-      <p:grpSpPr/>
+      <p:grpSpPr>
+        <a:xfrm>
+          <a:off x="0" y="0"/>
+          <a:ext cx="0" cy="0"/>
+          <a:chOff x="0" y="0"/>
+          <a:chExt cx="0" cy="0"/>
+        </a:xfrm>
+      </p:grpSpPr>
       <p:sp>
         <p:nvSpPr>
           <p:cNvPr id="2" name="TextBox 1"/>
@@ -3809,7 +4920,7 @@
 </file>
 
 <file path=ppt/slides/slide4.xml><?xml version="1.0" encoding="utf-8"?>
-<p:sld xmlns:a="http://schemas.openxmlformats.org/drawingml/2006/main" xmlns:p="http://schemas.openxmlformats.org/presentationml/2006/main" xmlns:r="http://schemas.openxmlformats.org/officeDocument/2006/relationships">
+<p:sld xmlns:a="http://schemas.openxmlformats.org/drawingml/2006/main" xmlns:r="http://schemas.openxmlformats.org/officeDocument/2006/relationships" xmlns:p="http://schemas.openxmlformats.org/presentationml/2006/main">
   <p:cSld>
     <p:bg>
       <p:bgPr>
@@ -3825,7 +4936,14 @@
         <p:cNvGrpSpPr/>
         <p:nvPr/>
       </p:nvGrpSpPr>
-      <p:grpSpPr/>
+      <p:grpSpPr>
+        <a:xfrm>
+          <a:off x="0" y="0"/>
+          <a:ext cx="0" cy="0"/>
+          <a:chOff x="0" y="0"/>
+          <a:chExt cx="0" cy="0"/>
+        </a:xfrm>
+      </p:grpSpPr>
       <p:sp>
         <p:nvSpPr>
           <p:cNvPr id="2" name="TextBox 1"/>
@@ -4122,7 +5240,7 @@
 </file>
 
 <file path=ppt/slides/slide5.xml><?xml version="1.0" encoding="utf-8"?>
-<p:sld xmlns:a="http://schemas.openxmlformats.org/drawingml/2006/main" xmlns:p="http://schemas.openxmlformats.org/presentationml/2006/main" xmlns:r="http://schemas.openxmlformats.org/officeDocument/2006/relationships">
+<p:sld xmlns:a="http://schemas.openxmlformats.org/drawingml/2006/main" xmlns:r="http://schemas.openxmlformats.org/officeDocument/2006/relationships" xmlns:p="http://schemas.openxmlformats.org/presentationml/2006/main">
   <p:cSld>
     <p:bg>
       <p:bgPr>
@@ -4138,7 +5256,14 @@
         <p:cNvGrpSpPr/>
         <p:nvPr/>
       </p:nvGrpSpPr>
-      <p:grpSpPr/>
+      <p:grpSpPr>
+        <a:xfrm>
+          <a:off x="0" y="0"/>
+          <a:ext cx="0" cy="0"/>
+          <a:chOff x="0" y="0"/>
+          <a:chExt cx="0" cy="0"/>
+        </a:xfrm>
+      </p:grpSpPr>
       <p:sp>
         <p:nvSpPr>
           <p:cNvPr id="2" name="TextBox 1"/>
@@ -4339,7 +5464,7 @@
 </file>
 
 <file path=ppt/slides/slide6.xml><?xml version="1.0" encoding="utf-8"?>
-<p:sld xmlns:a="http://schemas.openxmlformats.org/drawingml/2006/main" xmlns:p="http://schemas.openxmlformats.org/presentationml/2006/main" xmlns:r="http://schemas.openxmlformats.org/officeDocument/2006/relationships">
+<p:sld xmlns:a="http://schemas.openxmlformats.org/drawingml/2006/main" xmlns:r="http://schemas.openxmlformats.org/officeDocument/2006/relationships" xmlns:p="http://schemas.openxmlformats.org/presentationml/2006/main">
   <p:cSld>
     <p:bg>
       <p:bgPr>
@@ -4355,7 +5480,14 @@
         <p:cNvGrpSpPr/>
         <p:nvPr/>
       </p:nvGrpSpPr>
-      <p:grpSpPr/>
+      <p:grpSpPr>
+        <a:xfrm>
+          <a:off x="0" y="0"/>
+          <a:ext cx="0" cy="0"/>
+          <a:chOff x="0" y="0"/>
+          <a:chExt cx="0" cy="0"/>
+        </a:xfrm>
+      </p:grpSpPr>
       <p:sp>
         <p:nvSpPr>
           <p:cNvPr id="2" name="TextBox 1"/>
@@ -4620,7 +5752,7 @@
 </file>
 
 <file path=ppt/slides/slide7.xml><?xml version="1.0" encoding="utf-8"?>
-<p:sld xmlns:a="http://schemas.openxmlformats.org/drawingml/2006/main" xmlns:p="http://schemas.openxmlformats.org/presentationml/2006/main" xmlns:r="http://schemas.openxmlformats.org/officeDocument/2006/relationships">
+<p:sld xmlns:a="http://schemas.openxmlformats.org/drawingml/2006/main" xmlns:r="http://schemas.openxmlformats.org/officeDocument/2006/relationships" xmlns:p="http://schemas.openxmlformats.org/presentationml/2006/main">
   <p:cSld>
     <p:bg>
       <p:bgPr>
@@ -4636,7 +5768,14 @@
         <p:cNvGrpSpPr/>
         <p:nvPr/>
       </p:nvGrpSpPr>
-      <p:grpSpPr/>
+      <p:grpSpPr>
+        <a:xfrm>
+          <a:off x="0" y="0"/>
+          <a:ext cx="0" cy="0"/>
+          <a:chOff x="0" y="0"/>
+          <a:chExt cx="0" cy="0"/>
+        </a:xfrm>
+      </p:grpSpPr>
       <p:sp>
         <p:nvSpPr>
           <p:cNvPr id="2" name="TextBox 1"/>
@@ -4728,11 +5867,41 @@
                 <a:tableStyleId>{5C22544A-7EE6-4342-B048-85BDC9FD1C3A}</a:tableStyleId>
               </a:tblPr>
               <a:tblGrid>
-                <a:gridCol w="2286000"/>
-                <a:gridCol w="2743200"/>
-                <a:gridCol w="1371600"/>
-                <a:gridCol w="1371600"/>
-                <a:gridCol w="2587752"/>
+                <a:gridCol w="2286000">
+                  <a:extLst>
+                    <a:ext uri="{9D8B030D-6E8A-4147-A177-3AD203B41FA5}">
+                      <a16:colId xmlns:a16="http://schemas.microsoft.com/office/drawing/2014/main" val="20000"/>
+                    </a:ext>
+                  </a:extLst>
+                </a:gridCol>
+                <a:gridCol w="2743200">
+                  <a:extLst>
+                    <a:ext uri="{9D8B030D-6E8A-4147-A177-3AD203B41FA5}">
+                      <a16:colId xmlns:a16="http://schemas.microsoft.com/office/drawing/2014/main" val="20001"/>
+                    </a:ext>
+                  </a:extLst>
+                </a:gridCol>
+                <a:gridCol w="1371600">
+                  <a:extLst>
+                    <a:ext uri="{9D8B030D-6E8A-4147-A177-3AD203B41FA5}">
+                      <a16:colId xmlns:a16="http://schemas.microsoft.com/office/drawing/2014/main" val="20002"/>
+                    </a:ext>
+                  </a:extLst>
+                </a:gridCol>
+                <a:gridCol w="1371600">
+                  <a:extLst>
+                    <a:ext uri="{9D8B030D-6E8A-4147-A177-3AD203B41FA5}">
+                      <a16:colId xmlns:a16="http://schemas.microsoft.com/office/drawing/2014/main" val="20003"/>
+                    </a:ext>
+                  </a:extLst>
+                </a:gridCol>
+                <a:gridCol w="2587752">
+                  <a:extLst>
+                    <a:ext uri="{9D8B030D-6E8A-4147-A177-3AD203B41FA5}">
+                      <a16:colId xmlns:a16="http://schemas.microsoft.com/office/drawing/2014/main" val="20004"/>
+                    </a:ext>
+                  </a:extLst>
+                </a:gridCol>
               </a:tblGrid>
               <a:tr h="685800">
                 <a:tc>
@@ -4855,6 +6024,11 @@
                     </a:solidFill>
                   </a:tcPr>
                 </a:tc>
+                <a:extLst>
+                  <a:ext uri="{0D108BD9-81ED-4DB2-BD59-A6C34878D82A}">
+                    <a16:rowId xmlns:a16="http://schemas.microsoft.com/office/drawing/2014/main" val="10000"/>
+                  </a:ext>
+                </a:extLst>
               </a:tr>
               <a:tr h="685800">
                 <a:tc>
@@ -4977,6 +6151,11 @@
                     </a:solidFill>
                   </a:tcPr>
                 </a:tc>
+                <a:extLst>
+                  <a:ext uri="{0D108BD9-81ED-4DB2-BD59-A6C34878D82A}">
+                    <a16:rowId xmlns:a16="http://schemas.microsoft.com/office/drawing/2014/main" val="10001"/>
+                  </a:ext>
+                </a:extLst>
               </a:tr>
               <a:tr h="685800">
                 <a:tc>
@@ -5099,6 +6278,11 @@
                     </a:solidFill>
                   </a:tcPr>
                 </a:tc>
+                <a:extLst>
+                  <a:ext uri="{0D108BD9-81ED-4DB2-BD59-A6C34878D82A}">
+                    <a16:rowId xmlns:a16="http://schemas.microsoft.com/office/drawing/2014/main" val="10002"/>
+                  </a:ext>
+                </a:extLst>
               </a:tr>
               <a:tr h="685800">
                 <a:tc>
@@ -5221,6 +6405,11 @@
                     </a:solidFill>
                   </a:tcPr>
                 </a:tc>
+                <a:extLst>
+                  <a:ext uri="{0D108BD9-81ED-4DB2-BD59-A6C34878D82A}">
+                    <a16:rowId xmlns:a16="http://schemas.microsoft.com/office/drawing/2014/main" val="10003"/>
+                  </a:ext>
+                </a:extLst>
               </a:tr>
               <a:tr h="685800">
                 <a:tc>
@@ -5343,6 +6532,11 @@
                     </a:solidFill>
                   </a:tcPr>
                 </a:tc>
+                <a:extLst>
+                  <a:ext uri="{0D108BD9-81ED-4DB2-BD59-A6C34878D82A}">
+                    <a16:rowId xmlns:a16="http://schemas.microsoft.com/office/drawing/2014/main" val="10004"/>
+                  </a:ext>
+                </a:extLst>
               </a:tr>
               <a:tr h="685800">
                 <a:tc>
@@ -5465,6 +6659,11 @@
                     </a:solidFill>
                   </a:tcPr>
                 </a:tc>
+                <a:extLst>
+                  <a:ext uri="{0D108BD9-81ED-4DB2-BD59-A6C34878D82A}">
+                    <a16:rowId xmlns:a16="http://schemas.microsoft.com/office/drawing/2014/main" val="10005"/>
+                  </a:ext>
+                </a:extLst>
               </a:tr>
             </a:tbl>
           </a:graphicData>
@@ -5479,7 +6678,7 @@
 </file>
 
 <file path=ppt/slides/slide8.xml><?xml version="1.0" encoding="utf-8"?>
-<p:sld xmlns:a="http://schemas.openxmlformats.org/drawingml/2006/main" xmlns:p="http://schemas.openxmlformats.org/presentationml/2006/main" xmlns:r="http://schemas.openxmlformats.org/officeDocument/2006/relationships">
+<p:sld xmlns:a="http://schemas.openxmlformats.org/drawingml/2006/main" xmlns:r="http://schemas.openxmlformats.org/officeDocument/2006/relationships" xmlns:p="http://schemas.openxmlformats.org/presentationml/2006/main">
   <p:cSld>
     <p:bg>
       <p:bgPr>
@@ -5495,7 +6694,14 @@
         <p:cNvGrpSpPr/>
         <p:nvPr/>
       </p:nvGrpSpPr>
-      <p:grpSpPr/>
+      <p:grpSpPr>
+        <a:xfrm>
+          <a:off x="0" y="0"/>
+          <a:ext cx="0" cy="0"/>
+          <a:chOff x="0" y="0"/>
+          <a:chExt cx="0" cy="0"/>
+        </a:xfrm>
+      </p:grpSpPr>
       <p:sp>
         <p:nvSpPr>
           <p:cNvPr id="2" name="TextBox 1"/>
@@ -5760,7 +6966,7 @@
 </file>
 
 <file path=ppt/slides/slide9.xml><?xml version="1.0" encoding="utf-8"?>
-<p:sld xmlns:a="http://schemas.openxmlformats.org/drawingml/2006/main" xmlns:p="http://schemas.openxmlformats.org/presentationml/2006/main" xmlns:r="http://schemas.openxmlformats.org/officeDocument/2006/relationships">
+<p:sld xmlns:a="http://schemas.openxmlformats.org/drawingml/2006/main" xmlns:r="http://schemas.openxmlformats.org/officeDocument/2006/relationships" xmlns:p="http://schemas.openxmlformats.org/presentationml/2006/main">
   <p:cSld>
     <p:bg>
       <p:bgPr>
@@ -5776,7 +6982,14 @@
         <p:cNvGrpSpPr/>
         <p:nvPr/>
       </p:nvGrpSpPr>
-      <p:grpSpPr/>
+      <p:grpSpPr>
+        <a:xfrm>
+          <a:off x="0" y="0"/>
+          <a:ext cx="0" cy="0"/>
+          <a:chOff x="0" y="0"/>
+          <a:chExt cx="0" cy="0"/>
+        </a:xfrm>
+      </p:grpSpPr>
       <p:sp>
         <p:nvSpPr>
           <p:cNvPr id="2" name="TextBox 1"/>

</xml_diff>

<commit_message>
Final 8-slide presentation with personal reflection slide compiled to PPTX for Arabic and Hebrew
</commit_message>
<xml_diff>
--- a/final_presentation_slides_ar.pptx
+++ b/final_presentation_slides_ar.pptx
@@ -135,17 +135,25 @@
 <pc:chgInfo xmlns:a="http://schemas.openxmlformats.org/drawingml/2006/main" xmlns:r="http://schemas.openxmlformats.org/officeDocument/2006/relationships" xmlns:ac="http://schemas.microsoft.com/office/drawing/2013/main/command" xmlns:pc="http://schemas.microsoft.com/office/powerpoint/2013/main/command">
   <pc:docChgLst>
     <pc:chgData name="Noor Aioby" userId="38146ebc-8545-46bf-9d83-28dbd61da7d6" providerId="ADAL" clId="{9D132DA4-9AD7-4C07-B54E-5655E6903186}"/>
-    <pc:docChg chg="modSld">
-      <pc:chgData name="Noor Aioby" userId="38146ebc-8545-46bf-9d83-28dbd61da7d6" providerId="ADAL" clId="{9D132DA4-9AD7-4C07-B54E-5655E6903186}" dt="2026-07-09T07:05:25.257" v="0" actId="20577"/>
+    <pc:docChg chg="undo custSel modSld">
+      <pc:chgData name="Noor Aioby" userId="38146ebc-8545-46bf-9d83-28dbd61da7d6" providerId="ADAL" clId="{9D132DA4-9AD7-4C07-B54E-5655E6903186}" dt="2026-07-09T07:51:43.857" v="7" actId="20577"/>
       <pc:docMkLst>
         <pc:docMk/>
       </pc:docMkLst>
-      <pc:sldChg chg="modSp mod">
-        <pc:chgData name="Noor Aioby" userId="38146ebc-8545-46bf-9d83-28dbd61da7d6" providerId="ADAL" clId="{9D132DA4-9AD7-4C07-B54E-5655E6903186}" dt="2026-07-09T07:05:25.257" v="0" actId="20577"/>
+      <pc:sldChg chg="addSp delSp modSp mod">
+        <pc:chgData name="Noor Aioby" userId="38146ebc-8545-46bf-9d83-28dbd61da7d6" providerId="ADAL" clId="{9D132DA4-9AD7-4C07-B54E-5655E6903186}" dt="2026-07-09T07:51:43.857" v="7" actId="20577"/>
         <pc:sldMkLst>
           <pc:docMk/>
           <pc:sldMk cId="0" sldId="256"/>
         </pc:sldMkLst>
+        <pc:spChg chg="add del mod">
+          <ac:chgData name="Noor Aioby" userId="38146ebc-8545-46bf-9d83-28dbd61da7d6" providerId="ADAL" clId="{9D132DA4-9AD7-4C07-B54E-5655E6903186}" dt="2026-07-09T07:51:43.857" v="7" actId="20577"/>
+          <ac:spMkLst>
+            <pc:docMk/>
+            <pc:sldMk cId="0" sldId="256"/>
+            <ac:spMk id="3" creationId="{00000000-0000-0000-0000-000000000000}"/>
+          </ac:spMkLst>
+        </pc:spChg>
         <pc:spChg chg="mod">
           <ac:chgData name="Noor Aioby" userId="38146ebc-8545-46bf-9d83-28dbd61da7d6" providerId="ADAL" clId="{9D132DA4-9AD7-4C07-B54E-5655E6903186}" dt="2026-07-09T07:05:25.257" v="0" actId="20577"/>
           <ac:spMkLst>
@@ -3187,7 +3195,7 @@
         </p:nvSpPr>
         <p:spPr>
           <a:xfrm>
-            <a:off x="1371600" y="2286000"/>
+            <a:off x="1753737" y="2286000"/>
             <a:ext cx="9445752" cy="1828800"/>
           </a:xfrm>
           <a:prstGeom prst="rect">
@@ -3222,16 +3230,12 @@
               <a:t>القدس</a:t>
             </a:r>
             <a:r>
-              <a:rPr dirty="0"/>
-              <a:t> </a:t>
-            </a:r>
-            <a:r>
-              <a:rPr dirty="0" err="1"/>
-              <a:t>القانوني</a:t>
-            </a:r>
-            <a:r>
-              <a:rPr dirty="0"/>
-              <a:t> (JLM Legal Bridge)</a:t>
+              <a:rPr lang="ar-SA" dirty="0"/>
+              <a:t> القانوني (</a:t>
+            </a:r>
+            <a:r>
+              <a:rPr lang="en-US" dirty="0"/>
+              <a:t>JLM Legal Bridge)</a:t>
             </a:r>
           </a:p>
           <a:p>
@@ -3247,82 +3251,9 @@
               </a:defRPr>
             </a:pPr>
             <a:r>
-              <a:rPr dirty="0" err="1"/>
-              <a:t>منصة</a:t>
-            </a:r>
-            <a:r>
-              <a:rPr dirty="0"/>
-              <a:t> </a:t>
-            </a:r>
-            <a:r>
-              <a:rPr dirty="0" err="1"/>
-              <a:t>استبيان</a:t>
-            </a:r>
-            <a:r>
-              <a:rPr dirty="0"/>
-              <a:t> </a:t>
-            </a:r>
-            <a:r>
-              <a:rPr dirty="0" err="1"/>
-              <a:t>رقمية</a:t>
-            </a:r>
-            <a:r>
-              <a:rPr dirty="0"/>
-              <a:t> </a:t>
-            </a:r>
-            <a:r>
-              <a:rPr dirty="0" err="1"/>
-              <a:t>ذكية</a:t>
-            </a:r>
-            <a:r>
-              <a:rPr dirty="0"/>
-              <a:t> </a:t>
-            </a:r>
-            <a:r>
-              <a:rPr dirty="0" err="1"/>
-              <a:t>ومتوافقة</a:t>
-            </a:r>
-            <a:r>
-              <a:rPr dirty="0"/>
-              <a:t> </a:t>
-            </a:r>
-            <a:r>
-              <a:rPr dirty="0" err="1"/>
-              <a:t>ثقافياً</a:t>
-            </a:r>
-            <a:r>
-              <a:rPr dirty="0"/>
-              <a:t> </a:t>
-            </a:r>
-            <a:r>
-              <a:rPr dirty="0" err="1"/>
-              <a:t>للعمال</a:t>
-            </a:r>
-            <a:r>
-              <a:rPr dirty="0"/>
-              <a:t> </a:t>
-            </a:r>
-            <a:r>
-              <a:rPr dirty="0" err="1"/>
-              <a:t>في</a:t>
-            </a:r>
-            <a:r>
-              <a:rPr dirty="0"/>
-              <a:t> </a:t>
-            </a:r>
-            <a:r>
-              <a:rPr dirty="0" err="1"/>
-              <a:t>القدس</a:t>
-            </a:r>
-            <a:r>
-              <a:rPr dirty="0"/>
-              <a:t> </a:t>
-            </a:r>
-            <a:r>
-              <a:rPr dirty="0" err="1"/>
-              <a:t>الشرقية</a:t>
-            </a:r>
-            <a:endParaRPr dirty="0"/>
+              <a:rPr lang="ar-SA" dirty="0"/>
+              <a:t>منصة استبيان رقمية ذكية ومتوافقة ثقافياً للعمال في القدس الشرقية</a:t>
+            </a:r>
           </a:p>
         </p:txBody>
       </p:sp>

</xml_diff>